<commit_message>
feat: reduce deck to 5 slides, remove financial impact slide and streamline navigation to prototype
</commit_message>
<xml_diff>
--- a/PADRAO.pptx
+++ b/PADRAO.pptx
@@ -1,6 +1,6 @@
 
 <file path=ppt/presentation.xml><?xml version="1.0" encoding="utf-8"?>
-<p:presentation xmlns:a="http://schemas.openxmlformats.org/drawingml/2006/main" xmlns:r="http://schemas.openxmlformats.org/officeDocument/2006/relationships" xmlns:p="http://schemas.openxmlformats.org/presentationml/2006/main" saveSubsetFonts="1" embedTrueTypeFonts="true">
+<p:presentation xmlns:ns2="http://schemas.openxmlformats.org/drawingml/2006/main" xmlns:p="http://schemas.openxmlformats.org/presentationml/2006/main" xmlns:r="http://schemas.openxmlformats.org/officeDocument/2006/relationships" saveSubsetFonts="1" embedTrueTypeFonts="true">
   <p:sldMasterIdLst>
     <p:sldMasterId id="2147483648" r:id="rId1"/>
   </p:sldMasterIdLst>
@@ -8,7 +8,6 @@
     <p:sldId id="256" r:id="rId6"/>
     <p:sldId id="257" r:id="rId7"/>
     <p:sldId id="260" r:id="rId10"/>
-    <p:sldId id="261" r:id="rId11"/>
     <p:sldId id="262" r:id="rId12"/>
     <p:sldId id="263" r:id="rId13"/>
   </p:sldIdLst>
@@ -37,99 +36,99 @@
     </p:embeddedFont>
   </p:embeddedFontLst>
   <p:defaultTextStyle>
-    <a:defPPr>
-      <a:defRPr lang="en-US"/>
-    </a:defPPr>
-    <a:lvl1pPr marL="0" algn="l" defTabSz="914400" rtl="0" eaLnBrk="1" latinLnBrk="0" hangingPunct="1">
-      <a:defRPr sz="1800" kern="1200">
-        <a:solidFill>
-          <a:schemeClr val="tx1"/>
-        </a:solidFill>
-        <a:latin typeface="+mn-lt"/>
-        <a:ea typeface="+mn-ea"/>
-        <a:cs typeface="+mn-cs"/>
-      </a:defRPr>
-    </a:lvl1pPr>
-    <a:lvl2pPr marL="457200" algn="l" defTabSz="914400" rtl="0" eaLnBrk="1" latinLnBrk="0" hangingPunct="1">
-      <a:defRPr sz="1800" kern="1200">
-        <a:solidFill>
-          <a:schemeClr val="tx1"/>
-        </a:solidFill>
-        <a:latin typeface="+mn-lt"/>
-        <a:ea typeface="+mn-ea"/>
-        <a:cs typeface="+mn-cs"/>
-      </a:defRPr>
-    </a:lvl2pPr>
-    <a:lvl3pPr marL="914400" algn="l" defTabSz="914400" rtl="0" eaLnBrk="1" latinLnBrk="0" hangingPunct="1">
-      <a:defRPr sz="1800" kern="1200">
-        <a:solidFill>
-          <a:schemeClr val="tx1"/>
-        </a:solidFill>
-        <a:latin typeface="+mn-lt"/>
-        <a:ea typeface="+mn-ea"/>
-        <a:cs typeface="+mn-cs"/>
-      </a:defRPr>
-    </a:lvl3pPr>
-    <a:lvl4pPr marL="1371600" algn="l" defTabSz="914400" rtl="0" eaLnBrk="1" latinLnBrk="0" hangingPunct="1">
-      <a:defRPr sz="1800" kern="1200">
-        <a:solidFill>
-          <a:schemeClr val="tx1"/>
-        </a:solidFill>
-        <a:latin typeface="+mn-lt"/>
-        <a:ea typeface="+mn-ea"/>
-        <a:cs typeface="+mn-cs"/>
-      </a:defRPr>
-    </a:lvl4pPr>
-    <a:lvl5pPr marL="1828800" algn="l" defTabSz="914400" rtl="0" eaLnBrk="1" latinLnBrk="0" hangingPunct="1">
-      <a:defRPr sz="1800" kern="1200">
-        <a:solidFill>
-          <a:schemeClr val="tx1"/>
-        </a:solidFill>
-        <a:latin typeface="+mn-lt"/>
-        <a:ea typeface="+mn-ea"/>
-        <a:cs typeface="+mn-cs"/>
-      </a:defRPr>
-    </a:lvl5pPr>
-    <a:lvl6pPr marL="2286000" algn="l" defTabSz="914400" rtl="0" eaLnBrk="1" latinLnBrk="0" hangingPunct="1">
-      <a:defRPr sz="1800" kern="1200">
-        <a:solidFill>
-          <a:schemeClr val="tx1"/>
-        </a:solidFill>
-        <a:latin typeface="+mn-lt"/>
-        <a:ea typeface="+mn-ea"/>
-        <a:cs typeface="+mn-cs"/>
-      </a:defRPr>
-    </a:lvl6pPr>
-    <a:lvl7pPr marL="2743200" algn="l" defTabSz="914400" rtl="0" eaLnBrk="1" latinLnBrk="0" hangingPunct="1">
-      <a:defRPr sz="1800" kern="1200">
-        <a:solidFill>
-          <a:schemeClr val="tx1"/>
-        </a:solidFill>
-        <a:latin typeface="+mn-lt"/>
-        <a:ea typeface="+mn-ea"/>
-        <a:cs typeface="+mn-cs"/>
-      </a:defRPr>
-    </a:lvl7pPr>
-    <a:lvl8pPr marL="3200400" algn="l" defTabSz="914400" rtl="0" eaLnBrk="1" latinLnBrk="0" hangingPunct="1">
-      <a:defRPr sz="1800" kern="1200">
-        <a:solidFill>
-          <a:schemeClr val="tx1"/>
-        </a:solidFill>
-        <a:latin typeface="+mn-lt"/>
-        <a:ea typeface="+mn-ea"/>
-        <a:cs typeface="+mn-cs"/>
-      </a:defRPr>
-    </a:lvl8pPr>
-    <a:lvl9pPr marL="3657600" algn="l" defTabSz="914400" rtl="0" eaLnBrk="1" latinLnBrk="0" hangingPunct="1">
-      <a:defRPr sz="1800" kern="1200">
-        <a:solidFill>
-          <a:schemeClr val="tx1"/>
-        </a:solidFill>
-        <a:latin typeface="+mn-lt"/>
-        <a:ea typeface="+mn-ea"/>
-        <a:cs typeface="+mn-cs"/>
-      </a:defRPr>
-    </a:lvl9pPr>
+    <ns2:defPPr>
+      <ns2:defRPr lang="en-US"/>
+    </ns2:defPPr>
+    <ns2:lvl1pPr marL="0" algn="l" defTabSz="914400" rtl="0" eaLnBrk="1" latinLnBrk="0" hangingPunct="1">
+      <ns2:defRPr sz="1800" kern="1200">
+        <ns2:solidFill>
+          <ns2:schemeClr val="tx1"/>
+        </ns2:solidFill>
+        <ns2:latin typeface="+mn-lt"/>
+        <ns2:ea typeface="+mn-ea"/>
+        <ns2:cs typeface="+mn-cs"/>
+      </ns2:defRPr>
+    </ns2:lvl1pPr>
+    <ns2:lvl2pPr marL="457200" algn="l" defTabSz="914400" rtl="0" eaLnBrk="1" latinLnBrk="0" hangingPunct="1">
+      <ns2:defRPr sz="1800" kern="1200">
+        <ns2:solidFill>
+          <ns2:schemeClr val="tx1"/>
+        </ns2:solidFill>
+        <ns2:latin typeface="+mn-lt"/>
+        <ns2:ea typeface="+mn-ea"/>
+        <ns2:cs typeface="+mn-cs"/>
+      </ns2:defRPr>
+    </ns2:lvl2pPr>
+    <ns2:lvl3pPr marL="914400" algn="l" defTabSz="914400" rtl="0" eaLnBrk="1" latinLnBrk="0" hangingPunct="1">
+      <ns2:defRPr sz="1800" kern="1200">
+        <ns2:solidFill>
+          <ns2:schemeClr val="tx1"/>
+        </ns2:solidFill>
+        <ns2:latin typeface="+mn-lt"/>
+        <ns2:ea typeface="+mn-ea"/>
+        <ns2:cs typeface="+mn-cs"/>
+      </ns2:defRPr>
+    </ns2:lvl3pPr>
+    <ns2:lvl4pPr marL="1371600" algn="l" defTabSz="914400" rtl="0" eaLnBrk="1" latinLnBrk="0" hangingPunct="1">
+      <ns2:defRPr sz="1800" kern="1200">
+        <ns2:solidFill>
+          <ns2:schemeClr val="tx1"/>
+        </ns2:solidFill>
+        <ns2:latin typeface="+mn-lt"/>
+        <ns2:ea typeface="+mn-ea"/>
+        <ns2:cs typeface="+mn-cs"/>
+      </ns2:defRPr>
+    </ns2:lvl4pPr>
+    <ns2:lvl5pPr marL="1828800" algn="l" defTabSz="914400" rtl="0" eaLnBrk="1" latinLnBrk="0" hangingPunct="1">
+      <ns2:defRPr sz="1800" kern="1200">
+        <ns2:solidFill>
+          <ns2:schemeClr val="tx1"/>
+        </ns2:solidFill>
+        <ns2:latin typeface="+mn-lt"/>
+        <ns2:ea typeface="+mn-ea"/>
+        <ns2:cs typeface="+mn-cs"/>
+      </ns2:defRPr>
+    </ns2:lvl5pPr>
+    <ns2:lvl6pPr marL="2286000" algn="l" defTabSz="914400" rtl="0" eaLnBrk="1" latinLnBrk="0" hangingPunct="1">
+      <ns2:defRPr sz="1800" kern="1200">
+        <ns2:solidFill>
+          <ns2:schemeClr val="tx1"/>
+        </ns2:solidFill>
+        <ns2:latin typeface="+mn-lt"/>
+        <ns2:ea typeface="+mn-ea"/>
+        <ns2:cs typeface="+mn-cs"/>
+      </ns2:defRPr>
+    </ns2:lvl6pPr>
+    <ns2:lvl7pPr marL="2743200" algn="l" defTabSz="914400" rtl="0" eaLnBrk="1" latinLnBrk="0" hangingPunct="1">
+      <ns2:defRPr sz="1800" kern="1200">
+        <ns2:solidFill>
+          <ns2:schemeClr val="tx1"/>
+        </ns2:solidFill>
+        <ns2:latin typeface="+mn-lt"/>
+        <ns2:ea typeface="+mn-ea"/>
+        <ns2:cs typeface="+mn-cs"/>
+      </ns2:defRPr>
+    </ns2:lvl7pPr>
+    <ns2:lvl8pPr marL="3200400" algn="l" defTabSz="914400" rtl="0" eaLnBrk="1" latinLnBrk="0" hangingPunct="1">
+      <ns2:defRPr sz="1800" kern="1200">
+        <ns2:solidFill>
+          <ns2:schemeClr val="tx1"/>
+        </ns2:solidFill>
+        <ns2:latin typeface="+mn-lt"/>
+        <ns2:ea typeface="+mn-ea"/>
+        <ns2:cs typeface="+mn-cs"/>
+      </ns2:defRPr>
+    </ns2:lvl8pPr>
+    <ns2:lvl9pPr marL="3657600" algn="l" defTabSz="914400" rtl="0" eaLnBrk="1" latinLnBrk="0" hangingPunct="1">
+      <ns2:defRPr sz="1800" kern="1200">
+        <ns2:solidFill>
+          <ns2:schemeClr val="tx1"/>
+        </ns2:solidFill>
+        <ns2:latin typeface="+mn-lt"/>
+        <ns2:ea typeface="+mn-ea"/>
+        <ns2:cs typeface="+mn-cs"/>
+      </ns2:defRPr>
+    </ns2:lvl9pPr>
   </p:defaultTextStyle>
 </p:presentation>
 </file>
@@ -9757,7 +9756,7 @@
               </a:defRPr>
             </a:pPr>
             <a:r>
-              <a:t>5</a:t>
+              <a:t>4</a:t>
             </a:r>
           </a:p>
         </p:txBody>
@@ -12334,7 +12333,7 @@
               </a:defRPr>
             </a:pPr>
             <a:r>
-              <a:t>6</a:t>
+              <a:t>5</a:t>
             </a:r>
           </a:p>
         </p:txBody>

</xml_diff>

<commit_message>
feat: update presentation cover title to Wizard Pattern and add official logo
</commit_message>
<xml_diff>
--- a/PADRAO.pptx
+++ b/PADRAO.pptx
@@ -3752,16 +3752,40 @@
           </p:txBody>
         </p:sp>
       </p:grpSp>
-      <p:sp>
-        <p:nvSpPr>
-          <p:cNvPr name="TextBox 23" id="23"/>
+      <p:pic xmlns:p="http://schemas.openxmlformats.org/presentationml/2006/main" xmlns:a="http://schemas.openxmlformats.org/drawingml/2006/main" xmlns:r="http://schemas.openxmlformats.org/officeDocument/2006/relationships">
+        <p:nvPicPr>
+          <p:cNvPr id="102" name="FullLogo"/>
+          <p:cNvPicPr>
+            <a:picLocks noChangeAspect="1"/>
+          </p:cNvPicPr>
+          <p:nvPr/>
+        </p:nvPicPr>
+        <p:blipFill>
+          <a:blip r:embed="rId2"/>
+          <a:stretch>
+            <a:fillRect/>
+          </a:stretch>
+        </p:blipFill>
+        <p:spPr>
+          <a:xfrm>
+            <a:off x="8883360" y="1400000"/>
+            <a:ext cx="5669280" cy="3394778"/>
+          </a:xfrm>
+          <a:prstGeom prst="rect">
+            <a:avLst/>
+          </a:prstGeom>
+        </p:spPr>
+      </p:pic>
+      <p:sp xmlns:p="http://schemas.openxmlformats.org/presentationml/2006/main" xmlns:a="http://schemas.openxmlformats.org/drawingml/2006/main">
+        <p:nvSpPr>
+          <p:cNvPr name="TextBox 25" id="25"/>
           <p:cNvSpPr txBox="true"/>
           <p:nvPr/>
         </p:nvSpPr>
         <p:spPr>
           <a:xfrm rot="0">
-            <a:off x="5486400" y="2468880"/>
-            <a:ext cx="12435840" cy="1188720"/>
+            <a:off x="5486400" y="5300000"/>
+            <a:ext cx="12435840" cy="2926080"/>
           </a:xfrm>
           <a:prstGeom prst="rect">
             <a:avLst/>
@@ -3775,86 +3799,10 @@
           <a:p>
             <a:pPr algn="ctr">
               <a:lnSpc>
-                <a:spcPts val="7279"/>
-              </a:lnSpc>
-              <a:defRPr sz="5200" b="1">
-                <a:solidFill>
-                  <a:srgbClr val="3468A2"/>
-                </a:solidFill>
-                <a:latin typeface="Poppins"/>
-              </a:defRPr>
-            </a:pPr>
-            <a:r>
-              <a:t>ENTERPRISE MAIL</a:t>
-            </a:r>
-          </a:p>
-        </p:txBody>
-      </p:sp>
-      <p:sp>
-        <p:nvSpPr>
-          <p:cNvPr name="TextBox 24" id="24"/>
-          <p:cNvSpPr txBox="true"/>
-          <p:nvPr/>
-        </p:nvSpPr>
-        <p:spPr>
-          <a:xfrm rot="0">
-            <a:off x="5486400" y="3657600"/>
-            <a:ext cx="12435840" cy="1097280"/>
-          </a:xfrm>
-          <a:prstGeom prst="rect">
-            <a:avLst/>
-          </a:prstGeom>
-        </p:spPr>
-        <p:txBody>
-          <a:bodyPr anchor="t" rtlCol="false" tIns="0" lIns="0" bIns="0" rIns="0" wrap="square">
-            <a:spAutoFit/>
-          </a:bodyPr>
-          <a:lstStyle/>
-          <a:p>
-            <a:pPr algn="ctr">
-              <a:lnSpc>
-                <a:spcPts val="5880"/>
-              </a:lnSpc>
-              <a:defRPr sz="4200" b="1">
-                <a:solidFill>
-                  <a:srgbClr val="1F497D"/>
-                </a:solidFill>
-                <a:latin typeface="Poppins"/>
-              </a:defRPr>
-            </a:pPr>
-            <a:r>
-              <a:t>SETUP WIZARD</a:t>
-            </a:r>
-          </a:p>
-        </p:txBody>
-      </p:sp>
-      <p:sp>
-        <p:nvSpPr>
-          <p:cNvPr name="TextBox 25" id="25"/>
-          <p:cNvSpPr txBox="true"/>
-          <p:nvPr/>
-        </p:nvSpPr>
-        <p:spPr>
-          <a:xfrm rot="0">
-            <a:off x="5486400" y="5212080"/>
-            <a:ext cx="12435840" cy="2926080"/>
-          </a:xfrm>
-          <a:prstGeom prst="rect">
-            <a:avLst/>
-          </a:prstGeom>
-        </p:spPr>
-        <p:txBody>
-          <a:bodyPr anchor="t" rtlCol="false" tIns="0" lIns="0" bIns="0" rIns="0" wrap="square">
-            <a:spAutoFit/>
-          </a:bodyPr>
-          <a:lstStyle/>
-          <a:p>
-            <a:pPr algn="ctr">
-              <a:lnSpc>
                 <a:spcPts val="4480"/>
               </a:lnSpc>
               <a:spcAft>
-                <a:spcPts val="2400"/>
+                <a:spcPts val="2800"/>
               </a:spcAft>
               <a:defRPr sz="2200" b="0">
                 <a:solidFill>

</xml_diff>